<commit_message>
Update lesson materials and add logistics package and school poster
</commit_message>
<xml_diff>
--- a/classes/field_assignments/files/know-when-to-leave-presentation-template.pptx
+++ b/classes/field_assignments/files/know-when-to-leave-presentation-template.pptx
@@ -74,7 +74,7 @@
         <p:txBody>
           <a:bodyPr/>
           <a:p>
-            <a:fld id="{DBE66A45-0D6E-433C-BE01-17F204844579}" type="slidenum">
+            <a:fld id="{D6D79473-5976-4FD4-A4D1-A371C30365C8}" type="slidenum">
               <a:t>&lt;#&gt;</a:t>
             </a:fld>
           </a:p>
@@ -237,7 +237,7 @@
         <p:txBody>
           <a:bodyPr/>
           <a:p>
-            <a:fld id="{17027DAC-EFA2-4A95-917C-5DFB1ADD3419}" type="slidenum">
+            <a:fld id="{DFBA612F-7E4F-4F53-AD2E-745152C475BF}" type="slidenum">
               <a:t>&lt;#&gt;</a:t>
             </a:fld>
           </a:p>
@@ -722,7 +722,7 @@
             <a:pPr indent="0" algn="r">
               <a:buNone/>
             </a:pPr>
-            <a:fld id="{D3D8B771-CA48-4395-846C-3B4A9281C2F0}" type="slidenum">
+            <a:fld id="{AAE36F42-F629-4D9B-8DF3-DEEC42DF1A14}" type="slidenum">
               <a:rPr b="0" lang="en-US" sz="1400" spc="-1" strike="noStrike">
                 <a:solidFill>
                   <a:srgbClr val="000000"/>
@@ -1160,7 +1160,7 @@
                 </a:solidFill>
                 <a:latin typeface="Arial"/>
               </a:rPr>
-              <a:t>OPTIONAL VISUAL</a:t>
+              <a:t>VISUAL</a:t>
             </a:r>
             <a:endParaRPr b="0" lang="en-US" sz="1400" spc="-1" strike="noStrike">
               <a:solidFill>
@@ -1177,7 +1177,7 @@
                 </a:solidFill>
                 <a:latin typeface="Arial"/>
               </a:rPr>
-              <a:t>Add a simple evacuation symbol, map fragment, or photo you are allowed to use.</a:t>
+              <a:t>Evacuation symbol, map fragment, or credited photo</a:t>
             </a:r>
             <a:endParaRPr b="0" lang="en-US" sz="1400" spc="-1" strike="noStrike">
               <a:solidFill>

</xml_diff>